<commit_message>
refactor: update team roster to Version Controllers (Ayush, Rishav, Hardik) without roles, update hackathon title to Hacktoberfest Hackathon 2026, and refresh decks
</commit_message>
<xml_diff>
--- a/CivicPulse_Hackathon_Pitch_Deck.pptx
+++ b/CivicPulse_Hackathon_Pitch_Deck.pptx
@@ -3146,7 +3146,7 @@
         <p:spPr>
           <a:xfrm>
             <a:off x="914400" y="731520"/>
-            <a:ext cx="4389120" cy="457200"/>
+            <a:ext cx="4754880" cy="457200"/>
           </a:xfrm>
           <a:prstGeom prst="roundRect">
             <a:avLst/>
@@ -3186,7 +3186,7 @@
               </a:defRPr>
             </a:pPr>
             <a:r>
-              <a:t>⚡ GOOGLE GEMMA HACKATHON 2026</a:t>
+              <a:t>⚡ Hacktoberfect Hackathon 2026</a:t>
             </a:r>
           </a:p>
         </p:txBody>
@@ -3293,8 +3293,8 @@
         </p:nvSpPr>
         <p:spPr>
           <a:xfrm>
-            <a:off x="914400" y="3749039"/>
-            <a:ext cx="2377440" cy="2286000"/>
+            <a:off x="914400" y="3840480"/>
+            <a:ext cx="3200400" cy="2011680"/>
           </a:xfrm>
           <a:prstGeom prst="roundRect">
             <a:avLst/>
@@ -3338,8 +3338,8 @@
         </p:nvSpPr>
         <p:spPr>
           <a:xfrm>
-            <a:off x="914400" y="3749039"/>
-            <a:ext cx="2377440" cy="91440"/>
+            <a:off x="914400" y="3840480"/>
+            <a:ext cx="3200400" cy="109728"/>
           </a:xfrm>
           <a:prstGeom prst="rect">
             <a:avLst/>
@@ -3383,8 +3383,8 @@
         </p:nvSpPr>
         <p:spPr>
           <a:xfrm>
-            <a:off x="1051560" y="3931920"/>
-            <a:ext cx="2103120" cy="2011680"/>
+            <a:off x="1097280" y="4297680"/>
+            <a:ext cx="2834640" cy="1280160"/>
           </a:xfrm>
           <a:prstGeom prst="rect">
             <a:avLst/>
@@ -3398,7 +3398,7 @@
           <a:lstStyle/>
           <a:p>
             <a:pPr>
-              <a:defRPr sz="1700" b="1">
+              <a:defRPr sz="2200" b="1">
                 <a:solidFill>
                   <a:srgbClr val="F8FAFC"/>
                 </a:solidFill>
@@ -3410,26 +3410,14 @@
           </a:p>
           <a:p>
             <a:pPr>
-              <a:defRPr sz="1200" b="1">
+              <a:defRPr sz="1300">
                 <a:solidFill>
                   <a:srgbClr val="6366F1"/>
                 </a:solidFill>
               </a:defRPr>
             </a:pPr>
             <a:r>
-              <a:t>Full-Stack &amp; AI Lead</a:t>
-            </a:r>
-          </a:p>
-          <a:p>
-            <a:pPr>
-              <a:defRPr sz="1100">
-                <a:solidFill>
-                  <a:srgbClr val="94A3B8"/>
-                </a:solidFill>
-              </a:defRPr>
-            </a:pPr>
-            <a:r>
-              <a:t>Gemma 4 pipeline, FastAPI backend, system orchestration</a:t>
+              <a:t>Team Version Controllers</a:t>
             </a:r>
           </a:p>
         </p:txBody>
@@ -3442,8 +3430,8 @@
         </p:nvSpPr>
         <p:spPr>
           <a:xfrm>
-            <a:off x="3575304" y="3749039"/>
-            <a:ext cx="2377440" cy="2286000"/>
+            <a:off x="4480560" y="3840480"/>
+            <a:ext cx="3200400" cy="2011680"/>
           </a:xfrm>
           <a:prstGeom prst="roundRect">
             <a:avLst/>
@@ -3487,8 +3475,8 @@
         </p:nvSpPr>
         <p:spPr>
           <a:xfrm>
-            <a:off x="3575304" y="3749039"/>
-            <a:ext cx="2377440" cy="91440"/>
+            <a:off x="4480560" y="3840480"/>
+            <a:ext cx="3200400" cy="109728"/>
           </a:xfrm>
           <a:prstGeom prst="rect">
             <a:avLst/>
@@ -3532,8 +3520,8 @@
         </p:nvSpPr>
         <p:spPr>
           <a:xfrm>
-            <a:off x="3712464" y="3931920"/>
-            <a:ext cx="2103120" cy="2011680"/>
+            <a:off x="4663440" y="4297680"/>
+            <a:ext cx="2834640" cy="1280160"/>
           </a:xfrm>
           <a:prstGeom prst="rect">
             <a:avLst/>
@@ -3547,7 +3535,7 @@
           <a:lstStyle/>
           <a:p>
             <a:pPr>
-              <a:defRPr sz="1700" b="1">
+              <a:defRPr sz="2200" b="1">
                 <a:solidFill>
                   <a:srgbClr val="F8FAFC"/>
                 </a:solidFill>
@@ -3559,26 +3547,14 @@
           </a:p>
           <a:p>
             <a:pPr>
-              <a:defRPr sz="1200" b="1">
+              <a:defRPr sz="1300">
                 <a:solidFill>
                   <a:srgbClr val="8B5CF6"/>
                 </a:solidFill>
               </a:defRPr>
             </a:pPr>
             <a:r>
-              <a:t>Backend &amp; Database</a:t>
-            </a:r>
-          </a:p>
-          <a:p>
-            <a:pPr>
-              <a:defRPr sz="1100">
-                <a:solidFill>
-                  <a:srgbClr val="94A3B8"/>
-                </a:solidFill>
-              </a:defRPr>
-            </a:pPr>
-            <a:r>
-              <a:t>SQLite schema design, fallback cascades, REST APIs</a:t>
+              <a:t>Team Version Controllers</a:t>
             </a:r>
           </a:p>
         </p:txBody>
@@ -3591,8 +3567,8 @@
         </p:nvSpPr>
         <p:spPr>
           <a:xfrm>
-            <a:off x="6236208" y="3749039"/>
-            <a:ext cx="2377440" cy="2286000"/>
+            <a:off x="8046720" y="3840480"/>
+            <a:ext cx="3200400" cy="2011680"/>
           </a:xfrm>
           <a:prstGeom prst="roundRect">
             <a:avLst/>
@@ -3636,18 +3612,18 @@
         </p:nvSpPr>
         <p:spPr>
           <a:xfrm>
-            <a:off x="6236208" y="3749039"/>
-            <a:ext cx="2377440" cy="91440"/>
+            <a:off x="8046720" y="3840480"/>
+            <a:ext cx="3200400" cy="109728"/>
           </a:xfrm>
           <a:prstGeom prst="rect">
             <a:avLst/>
           </a:prstGeom>
           <a:solidFill>
-            <a:srgbClr val="F43F5E"/>
+            <a:srgbClr val="10B981"/>
           </a:solidFill>
           <a:ln>
             <a:solidFill>
-              <a:srgbClr val="F43F5E"/>
+              <a:srgbClr val="10B981"/>
             </a:solidFill>
           </a:ln>
         </p:spPr>
@@ -3681,8 +3657,8 @@
         </p:nvSpPr>
         <p:spPr>
           <a:xfrm>
-            <a:off x="6373368" y="3931920"/>
-            <a:ext cx="2103120" cy="2011680"/>
+            <a:off x="8229600" y="4297680"/>
+            <a:ext cx="2834640" cy="1280160"/>
           </a:xfrm>
           <a:prstGeom prst="rect">
             <a:avLst/>
@@ -3696,187 +3672,26 @@
           <a:lstStyle/>
           <a:p>
             <a:pPr>
-              <a:defRPr sz="1700" b="1">
+              <a:defRPr sz="2200" b="1">
                 <a:solidFill>
                   <a:srgbClr val="F8FAFC"/>
                 </a:solidFill>
               </a:defRPr>
             </a:pPr>
             <a:r>
-              <a:t>Radhika Sahay</a:t>
-            </a:r>
-          </a:p>
-          <a:p>
-            <a:pPr>
-              <a:defRPr sz="1200" b="1">
-                <a:solidFill>
-                  <a:srgbClr val="F43F5E"/>
-                </a:solidFill>
-              </a:defRPr>
-            </a:pPr>
-            <a:r>
-              <a:t>Frontend &amp; UI/UX</a:t>
-            </a:r>
-          </a:p>
-          <a:p>
-            <a:pPr>
-              <a:defRPr sz="1100">
-                <a:solidFill>
-                  <a:srgbClr val="94A3B8"/>
-                </a:solidFill>
-              </a:defRPr>
-            </a:pPr>
-            <a:r>
-              <a:t>Responsive design, micro-animations, citizen UX</a:t>
-            </a:r>
-          </a:p>
-        </p:txBody>
-      </p:sp>
-      <p:sp>
-        <p:nvSpPr>
-          <p:cNvPr id="15" name="Rounded Rectangle 14"/>
-          <p:cNvSpPr/>
-          <p:nvPr/>
-        </p:nvSpPr>
-        <p:spPr>
-          <a:xfrm>
-            <a:off x="8897112" y="3749039"/>
-            <a:ext cx="2377440" cy="2286000"/>
-          </a:xfrm>
-          <a:prstGeom prst="roundRect">
-            <a:avLst/>
-          </a:prstGeom>
-          <a:solidFill>
-            <a:srgbClr val="1E293B"/>
-          </a:solidFill>
-          <a:ln w="19050">
-            <a:solidFill>
-              <a:srgbClr val="334155"/>
-            </a:solidFill>
-          </a:ln>
-        </p:spPr>
-        <p:style>
-          <a:lnRef idx="1">
-            <a:schemeClr val="accent1"/>
-          </a:lnRef>
-          <a:fillRef idx="3">
-            <a:schemeClr val="accent1"/>
-          </a:fillRef>
-          <a:effectRef idx="2">
-            <a:schemeClr val="accent1"/>
-          </a:effectRef>
-          <a:fontRef idx="minor">
-            <a:schemeClr val="lt1"/>
-          </a:fontRef>
-        </p:style>
-        <p:txBody>
-          <a:bodyPr rtlCol="0" anchor="ctr"/>
-          <a:lstStyle/>
-          <a:p>
-            <a:pPr algn="ctr"/>
-          </a:p>
-        </p:txBody>
-      </p:sp>
-      <p:sp>
-        <p:nvSpPr>
-          <p:cNvPr id="16" name="Rectangle 15"/>
-          <p:cNvSpPr/>
-          <p:nvPr/>
-        </p:nvSpPr>
-        <p:spPr>
-          <a:xfrm>
-            <a:off x="8897112" y="3749039"/>
-            <a:ext cx="2377440" cy="91440"/>
-          </a:xfrm>
-          <a:prstGeom prst="rect">
-            <a:avLst/>
-          </a:prstGeom>
-          <a:solidFill>
-            <a:srgbClr val="F59E0B"/>
-          </a:solidFill>
-          <a:ln>
-            <a:solidFill>
-              <a:srgbClr val="F59E0B"/>
-            </a:solidFill>
-          </a:ln>
-        </p:spPr>
-        <p:style>
-          <a:lnRef idx="1">
-            <a:schemeClr val="accent1"/>
-          </a:lnRef>
-          <a:fillRef idx="3">
-            <a:schemeClr val="accent1"/>
-          </a:fillRef>
-          <a:effectRef idx="2">
-            <a:schemeClr val="accent1"/>
-          </a:effectRef>
-          <a:fontRef idx="minor">
-            <a:schemeClr val="lt1"/>
-          </a:fontRef>
-        </p:style>
-        <p:txBody>
-          <a:bodyPr rtlCol="0" anchor="ctr"/>
-          <a:lstStyle/>
-          <a:p>
-            <a:pPr algn="ctr"/>
-          </a:p>
-        </p:txBody>
-      </p:sp>
-      <p:sp>
-        <p:nvSpPr>
-          <p:cNvPr id="17" name="TextBox 16"/>
-          <p:cNvSpPr txBox="1"/>
-          <p:nvPr/>
-        </p:nvSpPr>
-        <p:spPr>
-          <a:xfrm>
-            <a:off x="9034272" y="3931920"/>
-            <a:ext cx="2103120" cy="2011680"/>
-          </a:xfrm>
-          <a:prstGeom prst="rect">
-            <a:avLst/>
-          </a:prstGeom>
-          <a:noFill/>
-        </p:spPr>
-        <p:txBody>
-          <a:bodyPr wrap="square">
-            <a:spAutoFit/>
-          </a:bodyPr>
-          <a:lstStyle/>
-          <a:p>
-            <a:pPr>
-              <a:defRPr sz="1700" b="1">
-                <a:solidFill>
-                  <a:srgbClr val="F8FAFC"/>
-                </a:solidFill>
-              </a:defRPr>
-            </a:pPr>
-            <a:r>
               <a:t>Hardik Kumar</a:t>
             </a:r>
           </a:p>
           <a:p>
             <a:pPr>
-              <a:defRPr sz="1200" b="1">
-                <a:solidFill>
-                  <a:srgbClr val="F59E0B"/>
-                </a:solidFill>
-              </a:defRPr>
-            </a:pPr>
-            <a:r>
-              <a:t>AI Data &amp; QA</a:t>
-            </a:r>
-          </a:p>
-          <a:p>
-            <a:pPr>
-              <a:defRPr sz="1100">
-                <a:solidFill>
-                  <a:srgbClr val="94A3B8"/>
-                </a:solidFill>
-              </a:defRPr>
-            </a:pPr>
-            <a:r>
-              <a:t>Multimodal prompt engineering, edge testing, validation</a:t>
+              <a:defRPr sz="1300">
+                <a:solidFill>
+                  <a:srgbClr val="10B981"/>
+                </a:solidFill>
+              </a:defRPr>
+            </a:pPr>
+            <a:r>
+              <a:t>Team Version Controllers</a:t>
             </a:r>
           </a:p>
         </p:txBody>

</xml_diff>

<commit_message>
feat: display team roles (Team Leader, Member 1, Member 2) matching README across website and pitch deck
</commit_message>
<xml_diff>
--- a/CivicPulse_Hackathon_Pitch_Deck.pptx
+++ b/CivicPulse_Hackathon_Pitch_Deck.pptx
@@ -3383,8 +3383,8 @@
         </p:nvSpPr>
         <p:spPr>
           <a:xfrm>
-            <a:off x="1097280" y="4297680"/>
-            <a:ext cx="2834640" cy="1280160"/>
+            <a:off x="1097280" y="4114800"/>
+            <a:ext cx="2834640" cy="1554480"/>
           </a:xfrm>
           <a:prstGeom prst="rect">
             <a:avLst/>
@@ -3410,9 +3410,21 @@
           </a:p>
           <a:p>
             <a:pPr>
-              <a:defRPr sz="1300">
+              <a:defRPr sz="1400" b="1">
                 <a:solidFill>
                   <a:srgbClr val="6366F1"/>
+                </a:solidFill>
+              </a:defRPr>
+            </a:pPr>
+            <a:r>
+              <a:t>Team Leader</a:t>
+            </a:r>
+          </a:p>
+          <a:p>
+            <a:pPr>
+              <a:defRPr sz="1100">
+                <a:solidFill>
+                  <a:srgbClr val="94A3B8"/>
                 </a:solidFill>
               </a:defRPr>
             </a:pPr>
@@ -3520,8 +3532,8 @@
         </p:nvSpPr>
         <p:spPr>
           <a:xfrm>
-            <a:off x="4663440" y="4297680"/>
-            <a:ext cx="2834640" cy="1280160"/>
+            <a:off x="4663440" y="4114800"/>
+            <a:ext cx="2834640" cy="1554480"/>
           </a:xfrm>
           <a:prstGeom prst="rect">
             <a:avLst/>
@@ -3547,9 +3559,21 @@
           </a:p>
           <a:p>
             <a:pPr>
-              <a:defRPr sz="1300">
+              <a:defRPr sz="1400" b="1">
                 <a:solidFill>
                   <a:srgbClr val="8B5CF6"/>
+                </a:solidFill>
+              </a:defRPr>
+            </a:pPr>
+            <a:r>
+              <a:t>Member 1</a:t>
+            </a:r>
+          </a:p>
+          <a:p>
+            <a:pPr>
+              <a:defRPr sz="1100">
+                <a:solidFill>
+                  <a:srgbClr val="94A3B8"/>
                 </a:solidFill>
               </a:defRPr>
             </a:pPr>
@@ -3657,8 +3681,8 @@
         </p:nvSpPr>
         <p:spPr>
           <a:xfrm>
-            <a:off x="8229600" y="4297680"/>
-            <a:ext cx="2834640" cy="1280160"/>
+            <a:off x="8229600" y="4114800"/>
+            <a:ext cx="2834640" cy="1554480"/>
           </a:xfrm>
           <a:prstGeom prst="rect">
             <a:avLst/>
@@ -3684,9 +3708,21 @@
           </a:p>
           <a:p>
             <a:pPr>
-              <a:defRPr sz="1300">
+              <a:defRPr sz="1400" b="1">
                 <a:solidFill>
                   <a:srgbClr val="10B981"/>
+                </a:solidFill>
+              </a:defRPr>
+            </a:pPr>
+            <a:r>
+              <a:t>Member 2</a:t>
+            </a:r>
+          </a:p>
+          <a:p>
+            <a:pPr>
+              <a:defRPr sz="1100">
+                <a:solidFill>
+                  <a:srgbClr val="94A3B8"/>
                 </a:solidFill>
               </a:defRPr>
             </a:pPr>

</xml_diff>